<commit_message>
Reframe handover timeline as program/ownership handover (not process transition)
Correct the model: this is the handover of the SSC & technology
transformation program (designs, platforms, governance, roadmap,
capability) to RCPL's transformation team over 3 months — Month 1
Consolidate & Prepare, Month 2 Guided Ownership, Month 3 Independent
Run & Sign-off. Removes the operational shadow/reverse-shadow and
third-party rebadging framing that implied a process transition.

Co-Authored-By: Claude Opus 4.8 <noreply@anthropic.com>
Claude-Session: https://claude.ai/code/session_01Juybiu2FZBfTCtRrH4Amdz
</commit_message>
<xml_diff>
--- a/handover-timeline-slide.pptx
+++ b/handover-timeline-slide.pptx
@@ -932,7 +932,7 @@
                 <a:ea typeface="Calibri" pitchFamily="34" charset="-122"/>
                 <a:cs typeface="Calibri" pitchFamily="34" charset="-120"/>
               </a:rPr>
-              <a:t>Capability Transfer — 3-Month Handover Timeline</a:t>
+              <a:t>Program Handover — 3-Month Plan</a:t>
             </a:r>
             <a:endParaRPr lang="en-US" sz="2600" dirty="0"/>
           </a:p>
@@ -971,7 +971,7 @@
         <p:spPr>
           <a:xfrm>
             <a:off x="548640" y="1261872"/>
-            <a:ext cx="11064240" cy="365760"/>
+            <a:ext cx="11064240" cy="502920"/>
           </a:xfrm>
           <a:prstGeom prst="rect">
             <a:avLst/>
@@ -987,6 +987,20 @@
               <a:buNone/>
             </a:pPr>
             <a:r>
+              <a:rPr lang="en-US" sz="1250" b="1" dirty="0">
+                <a:solidFill>
+                  <a:srgbClr val="3F3F48"/>
+                </a:solidFill>
+                <a:latin typeface="Calibri" pitchFamily="34" charset="0"/>
+                <a:ea typeface="Calibri" pitchFamily="34" charset="-122"/>
+                <a:cs typeface="Calibri" pitchFamily="34" charset="-120"/>
+              </a:rPr>
+              <a:t>Handover of the SSC &amp; technology transformation program we delivered</a:t>
+            </a:r>
+            <a:pPr indent="0" marL="0">
+              <a:buNone/>
+            </a:pPr>
+            <a:r>
               <a:rPr lang="en-US" sz="1250" dirty="0">
                 <a:solidFill>
                   <a:srgbClr val="6A6A75"/>
@@ -995,7 +1009,7 @@
                 <a:ea typeface="Calibri" pitchFamily="34" charset="-122"/>
                 <a:cs typeface="Calibri" pitchFamily="34" charset="-120"/>
               </a:rPr>
-              <a:t>The final ~3 months of the programme (≈ M13–M15): EY hands the running operation to RCPL’s transformation team, gate by gate, to full independence.</a:t>
+              <a:t> — its designs, platforms (SSC, data lakehouse, AI factory, ERP), governance, roadmap &amp; capability — to RCPL’s transformation team. This is a program/ownership handover, not an operational process transition.</a:t>
             </a:r>
             <a:endParaRPr lang="en-US" sz="1250" dirty="0"/>
           </a:p>
@@ -1009,8 +1023,8 @@
         </p:nvSpPr>
         <p:spPr>
           <a:xfrm>
-            <a:off x="3685032" y="1783080"/>
-            <a:ext cx="2606040" cy="310896"/>
+            <a:off x="4096512" y="1874520"/>
+            <a:ext cx="2468880" cy="310896"/>
           </a:xfrm>
           <a:prstGeom prst="roundRect">
             <a:avLst>
@@ -1031,8 +1045,8 @@
         </p:nvSpPr>
         <p:spPr>
           <a:xfrm>
-            <a:off x="3657600" y="1783080"/>
-            <a:ext cx="2660904" cy="310896"/>
+            <a:off x="4069080" y="1874520"/>
+            <a:ext cx="2523744" cy="310896"/>
           </a:xfrm>
           <a:prstGeom prst="rect">
             <a:avLst/>
@@ -1056,7 +1070,21 @@
                 <a:ea typeface="Calibri" pitchFamily="34" charset="-122"/>
                 <a:cs typeface="Calibri" pitchFamily="34" charset="-120"/>
               </a:rPr>
-              <a:t>Month 1</a:t>
+              <a:t>Month 1  </a:t>
+            </a:r>
+            <a:pPr algn="ctr" indent="0" marL="0">
+              <a:buNone/>
+            </a:pPr>
+            <a:r>
+              <a:rPr lang="en-US" sz="1000" dirty="0">
+                <a:solidFill>
+                  <a:srgbClr val="6A6A75"/>
+                </a:solidFill>
+                <a:latin typeface="Calibri" pitchFamily="34" charset="0"/>
+                <a:ea typeface="Calibri" pitchFamily="34" charset="-122"/>
+                <a:cs typeface="Calibri" pitchFamily="34" charset="-120"/>
+              </a:rPr>
+              <a:t>· Consolidate &amp; Prepare</a:t>
             </a:r>
             <a:endParaRPr lang="en-US" sz="1200" dirty="0"/>
           </a:p>
@@ -1070,8 +1098,8 @@
         </p:nvSpPr>
         <p:spPr>
           <a:xfrm>
-            <a:off x="6345936" y="1783080"/>
-            <a:ext cx="2606040" cy="310896"/>
+            <a:off x="6620256" y="1874520"/>
+            <a:ext cx="2468880" cy="310896"/>
           </a:xfrm>
           <a:prstGeom prst="roundRect">
             <a:avLst>
@@ -1092,8 +1120,8 @@
         </p:nvSpPr>
         <p:spPr>
           <a:xfrm>
-            <a:off x="6318504" y="1783080"/>
-            <a:ext cx="2660904" cy="310896"/>
+            <a:off x="6592824" y="1874520"/>
+            <a:ext cx="2523744" cy="310896"/>
           </a:xfrm>
           <a:prstGeom prst="rect">
             <a:avLst/>
@@ -1117,7 +1145,21 @@
                 <a:ea typeface="Calibri" pitchFamily="34" charset="-122"/>
                 <a:cs typeface="Calibri" pitchFamily="34" charset="-120"/>
               </a:rPr>
-              <a:t>Month 2</a:t>
+              <a:t>Month 2  </a:t>
+            </a:r>
+            <a:pPr algn="ctr" indent="0" marL="0">
+              <a:buNone/>
+            </a:pPr>
+            <a:r>
+              <a:rPr lang="en-US" sz="1000" dirty="0">
+                <a:solidFill>
+                  <a:srgbClr val="6A6A75"/>
+                </a:solidFill>
+                <a:latin typeface="Calibri" pitchFamily="34" charset="0"/>
+                <a:ea typeface="Calibri" pitchFamily="34" charset="-122"/>
+                <a:cs typeface="Calibri" pitchFamily="34" charset="-120"/>
+              </a:rPr>
+              <a:t>· Guided Ownership</a:t>
             </a:r>
             <a:endParaRPr lang="en-US" sz="1200" dirty="0"/>
           </a:p>
@@ -1131,8 +1173,8 @@
         </p:nvSpPr>
         <p:spPr>
           <a:xfrm>
-            <a:off x="9006840" y="1783080"/>
-            <a:ext cx="2606040" cy="310896"/>
+            <a:off x="9144000" y="1874520"/>
+            <a:ext cx="2468880" cy="310896"/>
           </a:xfrm>
           <a:prstGeom prst="roundRect">
             <a:avLst>
@@ -1153,8 +1195,8 @@
         </p:nvSpPr>
         <p:spPr>
           <a:xfrm>
-            <a:off x="8979408" y="1783080"/>
-            <a:ext cx="2660904" cy="310896"/>
+            <a:off x="9116568" y="1874520"/>
+            <a:ext cx="2523744" cy="310896"/>
           </a:xfrm>
           <a:prstGeom prst="rect">
             <a:avLst/>
@@ -1178,7 +1220,21 @@
                 <a:ea typeface="Calibri" pitchFamily="34" charset="-122"/>
                 <a:cs typeface="Calibri" pitchFamily="34" charset="-120"/>
               </a:rPr>
-              <a:t>Month 3</a:t>
+              <a:t>Month 3  </a:t>
+            </a:r>
+            <a:pPr algn="ctr" indent="0" marL="0">
+              <a:buNone/>
+            </a:pPr>
+            <a:r>
+              <a:rPr lang="en-US" sz="1000" dirty="0">
+                <a:solidFill>
+                  <a:srgbClr val="6A6A75"/>
+                </a:solidFill>
+                <a:latin typeface="Calibri" pitchFamily="34" charset="0"/>
+                <a:ea typeface="Calibri" pitchFamily="34" charset="-122"/>
+                <a:cs typeface="Calibri" pitchFamily="34" charset="-120"/>
+              </a:rPr>
+              <a:t>· Independent Run &amp; Sign-off</a:t>
             </a:r>
             <a:endParaRPr lang="en-US" sz="1200" dirty="0"/>
           </a:p>
@@ -1192,8 +1248,8 @@
         </p:nvSpPr>
         <p:spPr>
           <a:xfrm>
-            <a:off x="3685032" y="2139696"/>
-            <a:ext cx="2606040" cy="420624"/>
+            <a:off x="4096512" y="2231136"/>
+            <a:ext cx="2468880" cy="420624"/>
           </a:xfrm>
           <a:prstGeom prst="roundRect">
             <a:avLst>
@@ -1214,8 +1270,8 @@
         </p:nvSpPr>
         <p:spPr>
           <a:xfrm>
-            <a:off x="3657600" y="2139696"/>
-            <a:ext cx="2660904" cy="420624"/>
+            <a:off x="4069080" y="2231136"/>
+            <a:ext cx="2523744" cy="420624"/>
           </a:xfrm>
           <a:prstGeom prst="rect">
             <a:avLst/>
@@ -1231,7 +1287,7 @@
               <a:buNone/>
             </a:pPr>
             <a:r>
-              <a:rPr lang="en-US" sz="1100" b="1" dirty="0">
+              <a:rPr lang="en-US" sz="1050" b="1" dirty="0">
                 <a:solidFill>
                   <a:srgbClr val="FFFFFF"/>
                 </a:solidFill>
@@ -1239,10 +1295,10 @@
                 <a:ea typeface="Calibri" pitchFamily="34" charset="-122"/>
                 <a:cs typeface="Calibri" pitchFamily="34" charset="-120"/>
               </a:rPr>
-              <a:t>Prepare &amp; Shadow
+              <a:t>EY packages the program
 </a:t>
             </a:r>
-            <a:endParaRPr lang="en-US" sz="1100" dirty="0"/>
+            <a:endParaRPr lang="en-US" sz="1050" dirty="0"/>
           </a:p>
           <a:p>
             <a:pPr algn="ctr" indent="0" marL="0">
@@ -1257,9 +1313,9 @@
                 <a:ea typeface="Calibri" pitchFamily="34" charset="-122"/>
                 <a:cs typeface="Calibri" pitchFamily="34" charset="-120"/>
               </a:rPr>
-              <a:t>RCPL observes · EY leads</a:t>
-            </a:r>
-            <a:endParaRPr lang="en-US" sz="1100" dirty="0"/>
+              <a:t>owners named · KT sessions</a:t>
+            </a:r>
+            <a:endParaRPr lang="en-US" sz="1050" dirty="0"/>
           </a:p>
         </p:txBody>
       </p:sp>
@@ -1271,8 +1327,8 @@
         </p:nvSpPr>
         <p:spPr>
           <a:xfrm>
-            <a:off x="6345936" y="2139696"/>
-            <a:ext cx="2606040" cy="420624"/>
+            <a:off x="6620256" y="2231136"/>
+            <a:ext cx="2468880" cy="420624"/>
           </a:xfrm>
           <a:prstGeom prst="roundRect">
             <a:avLst>
@@ -1293,8 +1349,8 @@
         </p:nvSpPr>
         <p:spPr>
           <a:xfrm>
-            <a:off x="6318504" y="2139696"/>
-            <a:ext cx="2660904" cy="420624"/>
+            <a:off x="6592824" y="2231136"/>
+            <a:ext cx="2523744" cy="420624"/>
           </a:xfrm>
           <a:prstGeom prst="rect">
             <a:avLst/>
@@ -1310,7 +1366,7 @@
               <a:buNone/>
             </a:pPr>
             <a:r>
-              <a:rPr lang="en-US" sz="1100" b="1" dirty="0">
+              <a:rPr lang="en-US" sz="1050" b="1" dirty="0">
                 <a:solidFill>
                   <a:srgbClr val="FFFFFF"/>
                 </a:solidFill>
@@ -1318,10 +1374,10 @@
                 <a:ea typeface="Calibri" pitchFamily="34" charset="-122"/>
                 <a:cs typeface="Calibri" pitchFamily="34" charset="-120"/>
               </a:rPr>
-              <a:t>Reverse-shadow &amp; Stabilise
+              <a:t>RCPL leads, EY alongside
 </a:t>
             </a:r>
-            <a:endParaRPr lang="en-US" sz="1100" dirty="0"/>
+            <a:endParaRPr lang="en-US" sz="1050" dirty="0"/>
           </a:p>
           <a:p>
             <a:pPr algn="ctr" indent="0" marL="0">
@@ -1336,9 +1392,9 @@
                 <a:ea typeface="Calibri" pitchFamily="34" charset="-122"/>
                 <a:cs typeface="Calibri" pitchFamily="34" charset="-120"/>
               </a:rPr>
-              <a:t>RCPL runs · EY supports</a:t>
-            </a:r>
-            <a:endParaRPr lang="en-US" sz="1100" dirty="0"/>
+              <a:t>assets &amp; operating models transfer</a:t>
+            </a:r>
+            <a:endParaRPr lang="en-US" sz="1050" dirty="0"/>
           </a:p>
         </p:txBody>
       </p:sp>
@@ -1350,8 +1406,8 @@
         </p:nvSpPr>
         <p:spPr>
           <a:xfrm>
-            <a:off x="9006840" y="2139696"/>
-            <a:ext cx="2606040" cy="420624"/>
+            <a:off x="9144000" y="2231136"/>
+            <a:ext cx="2468880" cy="420624"/>
           </a:xfrm>
           <a:prstGeom prst="roundRect">
             <a:avLst>
@@ -1372,8 +1428,8 @@
         </p:nvSpPr>
         <p:spPr>
           <a:xfrm>
-            <a:off x="8979408" y="2139696"/>
-            <a:ext cx="2660904" cy="420624"/>
+            <a:off x="9116568" y="2231136"/>
+            <a:ext cx="2523744" cy="420624"/>
           </a:xfrm>
           <a:prstGeom prst="rect">
             <a:avLst/>
@@ -1389,7 +1445,7 @@
               <a:buNone/>
             </a:pPr>
             <a:r>
-              <a:rPr lang="en-US" sz="1100" b="1" dirty="0">
+              <a:rPr lang="en-US" sz="1050" b="1" dirty="0">
                 <a:solidFill>
                   <a:srgbClr val="FFFFFF"/>
                 </a:solidFill>
@@ -1397,10 +1453,10 @@
                 <a:ea typeface="Calibri" pitchFamily="34" charset="-122"/>
                 <a:cs typeface="Calibri" pitchFamily="34" charset="-120"/>
               </a:rPr>
-              <a:t>RCPL-led → Sign-off
+              <a:t>RCPL owns, EY advisory
 </a:t>
             </a:r>
-            <a:endParaRPr lang="en-US" sz="1100" dirty="0"/>
+            <a:endParaRPr lang="en-US" sz="1050" dirty="0"/>
           </a:p>
           <a:p>
             <a:pPr algn="ctr" indent="0" marL="0">
@@ -1415,9 +1471,9 @@
                 <a:ea typeface="Calibri" pitchFamily="34" charset="-122"/>
                 <a:cs typeface="Calibri" pitchFamily="34" charset="-120"/>
               </a:rPr>
-              <a:t>RCPL owns · EY advisory</a:t>
-            </a:r>
-            <a:endParaRPr lang="en-US" sz="1100" dirty="0"/>
+              <a:t>assurance · sign-off</a:t>
+            </a:r>
+            <a:endParaRPr lang="en-US" sz="1050" dirty="0"/>
           </a:p>
         </p:txBody>
       </p:sp>
@@ -1429,8 +1485,8 @@
         </p:nvSpPr>
         <p:spPr>
           <a:xfrm>
-            <a:off x="4322826" y="2651760"/>
-            <a:ext cx="0" cy="3090672"/>
+            <a:off x="4700016" y="2743200"/>
+            <a:ext cx="0" cy="2926080"/>
           </a:xfrm>
           <a:prstGeom prst="line">
             <a:avLst/>
@@ -1452,8 +1508,8 @@
         </p:nvSpPr>
         <p:spPr>
           <a:xfrm>
-            <a:off x="4988052" y="2651760"/>
-            <a:ext cx="0" cy="3090672"/>
+            <a:off x="5330952" y="2743200"/>
+            <a:ext cx="0" cy="2926080"/>
           </a:xfrm>
           <a:prstGeom prst="line">
             <a:avLst/>
@@ -1475,8 +1531,8 @@
         </p:nvSpPr>
         <p:spPr>
           <a:xfrm>
-            <a:off x="5653278" y="2651760"/>
-            <a:ext cx="0" cy="3090672"/>
+            <a:off x="5961888" y="2743200"/>
+            <a:ext cx="0" cy="2926080"/>
           </a:xfrm>
           <a:prstGeom prst="line">
             <a:avLst/>
@@ -1498,8 +1554,8 @@
         </p:nvSpPr>
         <p:spPr>
           <a:xfrm>
-            <a:off x="6318504" y="2651760"/>
-            <a:ext cx="0" cy="3090672"/>
+            <a:off x="6592824" y="2743200"/>
+            <a:ext cx="0" cy="2926080"/>
           </a:xfrm>
           <a:prstGeom prst="line">
             <a:avLst/>
@@ -1521,8 +1577,8 @@
         </p:nvSpPr>
         <p:spPr>
           <a:xfrm>
-            <a:off x="6983730" y="2651760"/>
-            <a:ext cx="0" cy="3090672"/>
+            <a:off x="7223760" y="2743200"/>
+            <a:ext cx="0" cy="2926080"/>
           </a:xfrm>
           <a:prstGeom prst="line">
             <a:avLst/>
@@ -1544,8 +1600,8 @@
         </p:nvSpPr>
         <p:spPr>
           <a:xfrm>
-            <a:off x="7648956" y="2651760"/>
-            <a:ext cx="0" cy="3090672"/>
+            <a:off x="7854696" y="2743200"/>
+            <a:ext cx="0" cy="2926080"/>
           </a:xfrm>
           <a:prstGeom prst="line">
             <a:avLst/>
@@ -1567,8 +1623,8 @@
         </p:nvSpPr>
         <p:spPr>
           <a:xfrm>
-            <a:off x="8314182" y="2651760"/>
-            <a:ext cx="0" cy="3090672"/>
+            <a:off x="8485632" y="2743200"/>
+            <a:ext cx="0" cy="2926080"/>
           </a:xfrm>
           <a:prstGeom prst="line">
             <a:avLst/>
@@ -1590,8 +1646,8 @@
         </p:nvSpPr>
         <p:spPr>
           <a:xfrm>
-            <a:off x="8979408" y="2651760"/>
-            <a:ext cx="0" cy="3090672"/>
+            <a:off x="9116568" y="2743200"/>
+            <a:ext cx="0" cy="2926080"/>
           </a:xfrm>
           <a:prstGeom prst="line">
             <a:avLst/>
@@ -1613,8 +1669,8 @@
         </p:nvSpPr>
         <p:spPr>
           <a:xfrm>
-            <a:off x="9644634" y="2651760"/>
-            <a:ext cx="0" cy="3090672"/>
+            <a:off x="9747504" y="2743200"/>
+            <a:ext cx="0" cy="2926080"/>
           </a:xfrm>
           <a:prstGeom prst="line">
             <a:avLst/>
@@ -1636,8 +1692,8 @@
         </p:nvSpPr>
         <p:spPr>
           <a:xfrm>
-            <a:off x="10309860" y="2651760"/>
-            <a:ext cx="0" cy="3090672"/>
+            <a:off x="10378440" y="2743200"/>
+            <a:ext cx="0" cy="2926080"/>
           </a:xfrm>
           <a:prstGeom prst="line">
             <a:avLst/>
@@ -1659,8 +1715,8 @@
         </p:nvSpPr>
         <p:spPr>
           <a:xfrm>
-            <a:off x="10975086" y="2651760"/>
-            <a:ext cx="0" cy="3090672"/>
+            <a:off x="11009376" y="2743200"/>
+            <a:ext cx="0" cy="2926080"/>
           </a:xfrm>
           <a:prstGeom prst="line">
             <a:avLst/>
@@ -1682,8 +1738,8 @@
         </p:nvSpPr>
         <p:spPr>
           <a:xfrm>
-            <a:off x="548640" y="2523744"/>
-            <a:ext cx="10972800" cy="182880"/>
+            <a:off x="548640" y="2798064"/>
+            <a:ext cx="3410712" cy="315468"/>
           </a:xfrm>
           <a:prstGeom prst="rect">
             <a:avLst/>
@@ -1699,30 +1755,52 @@
               <a:buNone/>
             </a:pPr>
             <a:r>
-              <a:rPr lang="en-US" sz="1050" b="1" dirty="0">
-                <a:solidFill>
-                  <a:srgbClr val="7A2A8F"/>
-                </a:solidFill>
-                <a:latin typeface="Calibri" pitchFamily="34" charset="0"/>
-                <a:ea typeface="Calibri" pitchFamily="34" charset="-122"/>
-                <a:cs typeface="Calibri" pitchFamily="34" charset="-120"/>
-              </a:rPr>
-              <a:t>Track A — Handover of operations to RCPL’s transformation team</a:t>
-            </a:r>
-            <a:endParaRPr lang="en-US" sz="1050" dirty="0"/>
-          </a:p>
-        </p:txBody>
-      </p:sp>
-      <p:sp>
-        <p:nvSpPr>
-          <p:cNvPr id="30" name="Text 26"/>
-          <p:cNvSpPr/>
-          <p:nvPr/>
-        </p:nvSpPr>
-        <p:spPr>
-          <a:xfrm>
-            <a:off x="548640" y="2724912"/>
-            <a:ext cx="3017520" cy="242316"/>
+              <a:rPr lang="en-US" sz="950" dirty="0">
+                <a:solidFill>
+                  <a:srgbClr val="3F3F48"/>
+                </a:solidFill>
+                <a:latin typeface="Calibri" pitchFamily="34" charset="0"/>
+                <a:ea typeface="Calibri" pitchFamily="34" charset="-122"/>
+                <a:cs typeface="Calibri" pitchFamily="34" charset="-120"/>
+              </a:rPr>
+              <a:t>Handover plan &amp; governance</a:t>
+            </a:r>
+            <a:endParaRPr lang="en-US" sz="950" dirty="0"/>
+          </a:p>
+        </p:txBody>
+      </p:sp>
+      <p:sp>
+        <p:nvSpPr>
+          <p:cNvPr id="30" name="Shape 26"/>
+          <p:cNvSpPr/>
+          <p:nvPr/>
+        </p:nvSpPr>
+        <p:spPr>
+          <a:xfrm>
+            <a:off x="4069080" y="2868930"/>
+            <a:ext cx="1261872" cy="210312"/>
+          </a:xfrm>
+          <a:prstGeom prst="roundRect">
+            <a:avLst>
+              <a:gd name="adj" fmla="val 21739"/>
+            </a:avLst>
+          </a:prstGeom>
+          <a:solidFill>
+            <a:srgbClr val="2E5FA3"/>
+          </a:solidFill>
+          <a:ln/>
+        </p:spPr>
+      </p:sp>
+      <p:sp>
+        <p:nvSpPr>
+          <p:cNvPr id="31" name="Text 27"/>
+          <p:cNvSpPr/>
+          <p:nvPr/>
+        </p:nvSpPr>
+        <p:spPr>
+          <a:xfrm>
+            <a:off x="548640" y="3113532"/>
+            <a:ext cx="3410712" cy="315468"/>
           </a:xfrm>
           <a:prstGeom prst="rect">
             <a:avLst/>
@@ -1746,7 +1824,7 @@
                 <a:ea typeface="Calibri" pitchFamily="34" charset="-122"/>
                 <a:cs typeface="Calibri" pitchFamily="34" charset="-120"/>
               </a:rPr>
-              <a:t>Transfer planning &amp; governance</a:t>
+              <a:t>Program asset consolidation &amp; documentation pack</a:t>
             </a:r>
             <a:endParaRPr lang="en-US" sz="950" dirty="0"/>
           </a:p>
@@ -1754,18 +1832,18 @@
       </p:sp>
       <p:sp>
         <p:nvSpPr>
-          <p:cNvPr id="31" name="Shape 27"/>
-          <p:cNvSpPr/>
-          <p:nvPr/>
-        </p:nvSpPr>
-        <p:spPr>
-          <a:xfrm>
-            <a:off x="3657600" y="2779776"/>
-            <a:ext cx="1330452" cy="169164"/>
+          <p:cNvPr id="32" name="Shape 28"/>
+          <p:cNvSpPr/>
+          <p:nvPr/>
+        </p:nvSpPr>
+        <p:spPr>
+          <a:xfrm>
+            <a:off x="4069080" y="3184398"/>
+            <a:ext cx="2523744" cy="210312"/>
           </a:xfrm>
           <a:prstGeom prst="roundRect">
             <a:avLst>
-              <a:gd name="adj" fmla="val 21622"/>
+              <a:gd name="adj" fmla="val 21739"/>
             </a:avLst>
           </a:prstGeom>
           <a:solidFill>
@@ -1776,14 +1854,14 @@
       </p:sp>
       <p:sp>
         <p:nvSpPr>
-          <p:cNvPr id="32" name="Text 28"/>
-          <p:cNvSpPr/>
-          <p:nvPr/>
-        </p:nvSpPr>
-        <p:spPr>
-          <a:xfrm>
-            <a:off x="548640" y="2967228"/>
-            <a:ext cx="3017520" cy="242316"/>
+          <p:cNvPr id="33" name="Text 29"/>
+          <p:cNvSpPr/>
+          <p:nvPr/>
+        </p:nvSpPr>
+        <p:spPr>
+          <a:xfrm>
+            <a:off x="548640" y="3429000"/>
+            <a:ext cx="3410712" cy="315468"/>
           </a:xfrm>
           <a:prstGeom prst="rect">
             <a:avLst/>
@@ -1807,7 +1885,7 @@
                 <a:ea typeface="Calibri" pitchFamily="34" charset="-122"/>
                 <a:cs typeface="Calibri" pitchFamily="34" charset="-120"/>
               </a:rPr>
-              <a:t>Handover playbook development</a:t>
+              <a:t>Named RCPL owners per domain (SSC · data · AI · ERP · gov)</a:t>
             </a:r>
             <a:endParaRPr lang="en-US" sz="950" dirty="0"/>
           </a:p>
@@ -1815,18 +1893,18 @@
       </p:sp>
       <p:sp>
         <p:nvSpPr>
-          <p:cNvPr id="33" name="Shape 29"/>
-          <p:cNvSpPr/>
-          <p:nvPr/>
-        </p:nvSpPr>
-        <p:spPr>
-          <a:xfrm>
-            <a:off x="3657600" y="3022092"/>
-            <a:ext cx="1995678" cy="169164"/>
+          <p:cNvPr id="34" name="Shape 30"/>
+          <p:cNvSpPr/>
+          <p:nvPr/>
+        </p:nvSpPr>
+        <p:spPr>
+          <a:xfrm>
+            <a:off x="4069080" y="3499866"/>
+            <a:ext cx="1892808" cy="210312"/>
           </a:xfrm>
           <a:prstGeom prst="roundRect">
             <a:avLst>
-              <a:gd name="adj" fmla="val 21622"/>
+              <a:gd name="adj" fmla="val 21739"/>
             </a:avLst>
           </a:prstGeom>
           <a:solidFill>
@@ -1837,14 +1915,14 @@
       </p:sp>
       <p:sp>
         <p:nvSpPr>
-          <p:cNvPr id="34" name="Text 30"/>
-          <p:cNvSpPr/>
-          <p:nvPr/>
-        </p:nvSpPr>
-        <p:spPr>
-          <a:xfrm>
-            <a:off x="548640" y="3209544"/>
-            <a:ext cx="3017520" cy="242316"/>
+          <p:cNvPr id="35" name="Text 31"/>
+          <p:cNvSpPr/>
+          <p:nvPr/>
+        </p:nvSpPr>
+        <p:spPr>
+          <a:xfrm>
+            <a:off x="548640" y="3744468"/>
+            <a:ext cx="3410712" cy="315468"/>
           </a:xfrm>
           <a:prstGeom prst="rect">
             <a:avLst/>
@@ -1868,7 +1946,7 @@
                 <a:ea typeface="Calibri" pitchFamily="34" charset="-122"/>
                 <a:cs typeface="Calibri" pitchFamily="34" charset="-120"/>
               </a:rPr>
-              <a:t>Knowledge capture &amp; shadowing</a:t>
+              <a:t>Knowledge-transfer sessions (design rationale, architecture, roadmap)</a:t>
             </a:r>
             <a:endParaRPr lang="en-US" sz="950" dirty="0"/>
           </a:p>
@@ -1876,36 +1954,36 @@
       </p:sp>
       <p:sp>
         <p:nvSpPr>
-          <p:cNvPr id="35" name="Shape 31"/>
-          <p:cNvSpPr/>
-          <p:nvPr/>
-        </p:nvSpPr>
-        <p:spPr>
-          <a:xfrm>
-            <a:off x="3657600" y="3264408"/>
-            <a:ext cx="2660904" cy="169164"/>
+          <p:cNvPr id="36" name="Shape 32"/>
+          <p:cNvSpPr/>
+          <p:nvPr/>
+        </p:nvSpPr>
+        <p:spPr>
+          <a:xfrm>
+            <a:off x="4700016" y="3815334"/>
+            <a:ext cx="3154680" cy="210312"/>
           </a:xfrm>
           <a:prstGeom prst="roundRect">
             <a:avLst>
-              <a:gd name="adj" fmla="val 21622"/>
+              <a:gd name="adj" fmla="val 21739"/>
             </a:avLst>
           </a:prstGeom>
           <a:solidFill>
-            <a:srgbClr val="2E5FA3"/>
-          </a:solidFill>
-          <a:ln/>
-        </p:spPr>
-      </p:sp>
-      <p:sp>
-        <p:nvSpPr>
-          <p:cNvPr id="36" name="Text 32"/>
-          <p:cNvSpPr/>
-          <p:nvPr/>
-        </p:nvSpPr>
-        <p:spPr>
-          <a:xfrm>
-            <a:off x="3657600" y="3264408"/>
-            <a:ext cx="2660904" cy="169164"/>
+            <a:srgbClr val="7A2A8F"/>
+          </a:solidFill>
+          <a:ln/>
+        </p:spPr>
+      </p:sp>
+      <p:sp>
+        <p:nvSpPr>
+          <p:cNvPr id="37" name="Text 33"/>
+          <p:cNvSpPr/>
+          <p:nvPr/>
+        </p:nvSpPr>
+        <p:spPr>
+          <a:xfrm>
+            <a:off x="548640" y="4059936"/>
+            <a:ext cx="3410712" cy="315468"/>
           </a:xfrm>
           <a:prstGeom prst="rect">
             <a:avLst/>
@@ -1917,34 +1995,56 @@
           <a:bodyPr wrap="square" lIns="0" tIns="0" rIns="0" bIns="0" rtlCol="0" anchor="ctr"/>
           <a:lstStyle/>
           <a:p>
-            <a:pPr algn="ctr" indent="0" marL="0">
-              <a:buNone/>
-            </a:pPr>
-            <a:r>
-              <a:rPr lang="en-US" sz="700" i="1" dirty="0">
-                <a:solidFill>
-                  <a:srgbClr val="FFFFFF"/>
-                </a:solidFill>
-                <a:latin typeface="Calibri" pitchFamily="34" charset="0"/>
-                <a:ea typeface="Calibri" pitchFamily="34" charset="-122"/>
-                <a:cs typeface="Calibri" pitchFamily="34" charset="-120"/>
-              </a:rPr>
-              <a:t>Gate 1</a:t>
-            </a:r>
-            <a:endParaRPr lang="en-US" sz="700" dirty="0"/>
-          </a:p>
-        </p:txBody>
-      </p:sp>
-      <p:sp>
-        <p:nvSpPr>
-          <p:cNvPr id="37" name="Text 33"/>
-          <p:cNvSpPr/>
-          <p:nvPr/>
-        </p:nvSpPr>
-        <p:spPr>
-          <a:xfrm>
-            <a:off x="548640" y="3451860"/>
-            <a:ext cx="3017520" cy="242316"/>
+            <a:pPr indent="0" marL="0">
+              <a:buNone/>
+            </a:pPr>
+            <a:r>
+              <a:rPr lang="en-US" sz="950" dirty="0">
+                <a:solidFill>
+                  <a:srgbClr val="3F3F48"/>
+                </a:solidFill>
+                <a:latin typeface="Calibri" pitchFamily="34" charset="0"/>
+                <a:ea typeface="Calibri" pitchFamily="34" charset="-122"/>
+                <a:cs typeface="Calibri" pitchFamily="34" charset="-120"/>
+              </a:rPr>
+              <a:t>Access, environments &amp; tooling ownership transfer</a:t>
+            </a:r>
+            <a:endParaRPr lang="en-US" sz="950" dirty="0"/>
+          </a:p>
+        </p:txBody>
+      </p:sp>
+      <p:sp>
+        <p:nvSpPr>
+          <p:cNvPr id="38" name="Shape 34"/>
+          <p:cNvSpPr/>
+          <p:nvPr/>
+        </p:nvSpPr>
+        <p:spPr>
+          <a:xfrm>
+            <a:off x="5330952" y="4130802"/>
+            <a:ext cx="2523744" cy="210312"/>
+          </a:xfrm>
+          <a:prstGeom prst="roundRect">
+            <a:avLst>
+              <a:gd name="adj" fmla="val 21739"/>
+            </a:avLst>
+          </a:prstGeom>
+          <a:solidFill>
+            <a:srgbClr val="7A2A8F"/>
+          </a:solidFill>
+          <a:ln/>
+        </p:spPr>
+      </p:sp>
+      <p:sp>
+        <p:nvSpPr>
+          <p:cNvPr id="39" name="Text 35"/>
+          <p:cNvSpPr/>
+          <p:nvPr/>
+        </p:nvSpPr>
+        <p:spPr>
+          <a:xfrm>
+            <a:off x="548640" y="4375404"/>
+            <a:ext cx="3410712" cy="315468"/>
           </a:xfrm>
           <a:prstGeom prst="rect">
             <a:avLst/>
@@ -1968,7 +2068,7 @@
                 <a:ea typeface="Calibri" pitchFamily="34" charset="-122"/>
                 <a:cs typeface="Calibri" pitchFamily="34" charset="-120"/>
               </a:rPr>
-              <a:t>SOPs / RACI / KPIs finalised · tooling handover</a:t>
+              <a:t>AI factory operating-model handover — run a live use-case cycle</a:t>
             </a:r>
             <a:endParaRPr lang="en-US" sz="950" dirty="0"/>
           </a:p>
@@ -1976,18 +2076,18 @@
       </p:sp>
       <p:sp>
         <p:nvSpPr>
-          <p:cNvPr id="38" name="Shape 34"/>
-          <p:cNvSpPr/>
-          <p:nvPr/>
-        </p:nvSpPr>
-        <p:spPr>
-          <a:xfrm>
-            <a:off x="4988052" y="3506724"/>
-            <a:ext cx="3326130" cy="169164"/>
+          <p:cNvPr id="40" name="Shape 36"/>
+          <p:cNvSpPr/>
+          <p:nvPr/>
+        </p:nvSpPr>
+        <p:spPr>
+          <a:xfrm>
+            <a:off x="5961888" y="4446270"/>
+            <a:ext cx="3785616" cy="210312"/>
           </a:xfrm>
           <a:prstGeom prst="roundRect">
             <a:avLst>
-              <a:gd name="adj" fmla="val 21622"/>
+              <a:gd name="adj" fmla="val 21739"/>
             </a:avLst>
           </a:prstGeom>
           <a:solidFill>
@@ -1998,14 +2098,14 @@
       </p:sp>
       <p:sp>
         <p:nvSpPr>
-          <p:cNvPr id="39" name="Text 35"/>
-          <p:cNvSpPr/>
-          <p:nvPr/>
-        </p:nvSpPr>
-        <p:spPr>
-          <a:xfrm>
-            <a:off x="548640" y="3694176"/>
-            <a:ext cx="3017520" cy="242316"/>
+          <p:cNvPr id="41" name="Text 37"/>
+          <p:cNvSpPr/>
+          <p:nvPr/>
+        </p:nvSpPr>
+        <p:spPr>
+          <a:xfrm>
+            <a:off x="548640" y="4690872"/>
+            <a:ext cx="3410712" cy="315468"/>
           </a:xfrm>
           <a:prstGeom prst="rect">
             <a:avLst/>
@@ -2029,7 +2129,7 @@
                 <a:ea typeface="Calibri" pitchFamily="34" charset="-122"/>
                 <a:cs typeface="Calibri" pitchFamily="34" charset="-120"/>
               </a:rPr>
-              <a:t>Reverse-shadow: RCPL runs, EY supports</a:t>
+              <a:t>Capability build — RCPL team training &amp; certification</a:t>
             </a:r>
             <a:endParaRPr lang="en-US" sz="950" dirty="0"/>
           </a:p>
@@ -2037,18 +2137,18 @@
       </p:sp>
       <p:sp>
         <p:nvSpPr>
-          <p:cNvPr id="40" name="Shape 36"/>
-          <p:cNvSpPr/>
-          <p:nvPr/>
-        </p:nvSpPr>
-        <p:spPr>
-          <a:xfrm>
-            <a:off x="5653278" y="3749040"/>
-            <a:ext cx="3326130" cy="169164"/>
+          <p:cNvPr id="42" name="Shape 38"/>
+          <p:cNvSpPr/>
+          <p:nvPr/>
+        </p:nvSpPr>
+        <p:spPr>
+          <a:xfrm>
+            <a:off x="5330952" y="4761738"/>
+            <a:ext cx="4416552" cy="210312"/>
           </a:xfrm>
           <a:prstGeom prst="roundRect">
             <a:avLst>
-              <a:gd name="adj" fmla="val 21622"/>
+              <a:gd name="adj" fmla="val 21739"/>
             </a:avLst>
           </a:prstGeom>
           <a:solidFill>
@@ -2059,14 +2159,14 @@
       </p:sp>
       <p:sp>
         <p:nvSpPr>
-          <p:cNvPr id="41" name="Text 37"/>
-          <p:cNvSpPr/>
-          <p:nvPr/>
-        </p:nvSpPr>
-        <p:spPr>
-          <a:xfrm>
-            <a:off x="5653278" y="3749040"/>
-            <a:ext cx="3326130" cy="169164"/>
+          <p:cNvPr id="43" name="Text 39"/>
+          <p:cNvSpPr/>
+          <p:nvPr/>
+        </p:nvSpPr>
+        <p:spPr>
+          <a:xfrm>
+            <a:off x="548640" y="5006340"/>
+            <a:ext cx="3410712" cy="315468"/>
           </a:xfrm>
           <a:prstGeom prst="rect">
             <a:avLst/>
@@ -2078,34 +2178,56 @@
           <a:bodyPr wrap="square" lIns="0" tIns="0" rIns="0" bIns="0" rtlCol="0" anchor="ctr"/>
           <a:lstStyle/>
           <a:p>
-            <a:pPr algn="ctr" indent="0" marL="0">
-              <a:buNone/>
-            </a:pPr>
-            <a:r>
-              <a:rPr lang="en-US" sz="700" i="1" dirty="0">
-                <a:solidFill>
-                  <a:srgbClr val="FFFFFF"/>
-                </a:solidFill>
-                <a:latin typeface="Calibri" pitchFamily="34" charset="0"/>
-                <a:ea typeface="Calibri" pitchFamily="34" charset="-122"/>
-                <a:cs typeface="Calibri" pitchFamily="34" charset="-120"/>
-              </a:rPr>
-              <a:t>Gate 2</a:t>
-            </a:r>
-            <a:endParaRPr lang="en-US" sz="700" dirty="0"/>
-          </a:p>
-        </p:txBody>
-      </p:sp>
-      <p:sp>
-        <p:nvSpPr>
-          <p:cNvPr id="42" name="Text 38"/>
-          <p:cNvSpPr/>
-          <p:nvPr/>
-        </p:nvSpPr>
-        <p:spPr>
-          <a:xfrm>
-            <a:off x="548640" y="3936492"/>
-            <a:ext cx="3017520" cy="242316"/>
+            <a:pPr indent="0" marL="0">
+              <a:buNone/>
+            </a:pPr>
+            <a:r>
+              <a:rPr lang="en-US" sz="950" dirty="0">
+                <a:solidFill>
+                  <a:srgbClr val="3F3F48"/>
+                </a:solidFill>
+                <a:latin typeface="Calibri" pitchFamily="34" charset="0"/>
+                <a:ea typeface="Calibri" pitchFamily="34" charset="-122"/>
+                <a:cs typeface="Calibri" pitchFamily="34" charset="-120"/>
+              </a:rPr>
+              <a:t>RCPL-led independent run — governance, roadmap &amp; AI factory (EY on-call)</a:t>
+            </a:r>
+            <a:endParaRPr lang="en-US" sz="950" dirty="0"/>
+          </a:p>
+        </p:txBody>
+      </p:sp>
+      <p:sp>
+        <p:nvSpPr>
+          <p:cNvPr id="44" name="Shape 40"/>
+          <p:cNvSpPr/>
+          <p:nvPr/>
+        </p:nvSpPr>
+        <p:spPr>
+          <a:xfrm>
+            <a:off x="9116568" y="5077206"/>
+            <a:ext cx="2523744" cy="210312"/>
+          </a:xfrm>
+          <a:prstGeom prst="roundRect">
+            <a:avLst>
+              <a:gd name="adj" fmla="val 21739"/>
+            </a:avLst>
+          </a:prstGeom>
+          <a:solidFill>
+            <a:srgbClr val="C10E5B"/>
+          </a:solidFill>
+          <a:ln/>
+        </p:spPr>
+      </p:sp>
+      <p:sp>
+        <p:nvSpPr>
+          <p:cNvPr id="45" name="Text 41"/>
+          <p:cNvSpPr/>
+          <p:nvPr/>
+        </p:nvSpPr>
+        <p:spPr>
+          <a:xfrm>
+            <a:off x="548640" y="5321808"/>
+            <a:ext cx="3410712" cy="315468"/>
           </a:xfrm>
           <a:prstGeom prst="rect">
             <a:avLst/>
@@ -2129,7 +2251,7 @@
                 <a:ea typeface="Calibri" pitchFamily="34" charset="-122"/>
                 <a:cs typeface="Calibri" pitchFamily="34" charset="-120"/>
               </a:rPr>
-              <a:t>Facility &amp; IT management handover</a:t>
+              <a:t>Transfer assurance, final sign-off &amp; advisory transition</a:t>
             </a:r>
             <a:endParaRPr lang="en-US" sz="950" dirty="0"/>
           </a:p>
@@ -2137,36 +2259,59 @@
       </p:sp>
       <p:sp>
         <p:nvSpPr>
-          <p:cNvPr id="43" name="Shape 39"/>
-          <p:cNvSpPr/>
-          <p:nvPr/>
-        </p:nvSpPr>
-        <p:spPr>
-          <a:xfrm>
-            <a:off x="6318504" y="3991356"/>
-            <a:ext cx="2660904" cy="169164"/>
+          <p:cNvPr id="46" name="Shape 42"/>
+          <p:cNvSpPr/>
+          <p:nvPr/>
+        </p:nvSpPr>
+        <p:spPr>
+          <a:xfrm>
+            <a:off x="9747504" y="5392674"/>
+            <a:ext cx="1892808" cy="210312"/>
           </a:xfrm>
           <a:prstGeom prst="roundRect">
             <a:avLst>
-              <a:gd name="adj" fmla="val 21622"/>
+              <a:gd name="adj" fmla="val 21739"/>
             </a:avLst>
           </a:prstGeom>
           <a:solidFill>
-            <a:srgbClr val="7A2A8F"/>
-          </a:solidFill>
-          <a:ln/>
-        </p:spPr>
-      </p:sp>
-      <p:sp>
-        <p:nvSpPr>
-          <p:cNvPr id="44" name="Text 40"/>
-          <p:cNvSpPr/>
-          <p:nvPr/>
-        </p:nvSpPr>
-        <p:spPr>
-          <a:xfrm>
-            <a:off x="548640" y="4178808"/>
-            <a:ext cx="3017520" cy="242316"/>
+            <a:srgbClr val="2F8F6A"/>
+          </a:solidFill>
+          <a:ln/>
+        </p:spPr>
+      </p:sp>
+      <p:sp>
+        <p:nvSpPr>
+          <p:cNvPr id="47" name="Shape 43"/>
+          <p:cNvSpPr/>
+          <p:nvPr/>
+        </p:nvSpPr>
+        <p:spPr>
+          <a:xfrm>
+            <a:off x="11640312" y="2743200"/>
+            <a:ext cx="0" cy="2926080"/>
+          </a:xfrm>
+          <a:prstGeom prst="line">
+            <a:avLst/>
+          </a:prstGeom>
+          <a:noFill/>
+          <a:ln w="15875">
+            <a:solidFill>
+              <a:srgbClr val="2F8F6A"/>
+            </a:solidFill>
+            <a:prstDash val="dash"/>
+          </a:ln>
+        </p:spPr>
+      </p:sp>
+      <p:sp>
+        <p:nvSpPr>
+          <p:cNvPr id="48" name="Text 44"/>
+          <p:cNvSpPr/>
+          <p:nvPr/>
+        </p:nvSpPr>
+        <p:spPr>
+          <a:xfrm>
+            <a:off x="9116568" y="2651760"/>
+            <a:ext cx="2523744" cy="164592"/>
           </a:xfrm>
           <a:prstGeom prst="rect">
             <a:avLst/>
@@ -2178,56 +2323,34 @@
           <a:bodyPr wrap="square" lIns="0" tIns="0" rIns="0" bIns="0" rtlCol="0" anchor="ctr"/>
           <a:lstStyle/>
           <a:p>
-            <a:pPr indent="0" marL="0">
-              <a:buNone/>
-            </a:pPr>
-            <a:r>
-              <a:rPr lang="en-US" sz="950" dirty="0">
-                <a:solidFill>
-                  <a:srgbClr val="3F3F48"/>
-                </a:solidFill>
-                <a:latin typeface="Calibri" pitchFamily="34" charset="0"/>
-                <a:ea typeface="Calibri" pitchFamily="34" charset="-122"/>
-                <a:cs typeface="Calibri" pitchFamily="34" charset="-120"/>
-              </a:rPr>
-              <a:t>RCPL-led operations, EY on-call</a:t>
-            </a:r>
-            <a:endParaRPr lang="en-US" sz="950" dirty="0"/>
-          </a:p>
-        </p:txBody>
-      </p:sp>
-      <p:sp>
-        <p:nvSpPr>
-          <p:cNvPr id="45" name="Shape 41"/>
-          <p:cNvSpPr/>
-          <p:nvPr/>
-        </p:nvSpPr>
-        <p:spPr>
-          <a:xfrm>
-            <a:off x="8314182" y="4233672"/>
-            <a:ext cx="2660904" cy="169164"/>
-          </a:xfrm>
-          <a:prstGeom prst="roundRect">
-            <a:avLst>
-              <a:gd name="adj" fmla="val 21622"/>
-            </a:avLst>
-          </a:prstGeom>
-          <a:solidFill>
-            <a:srgbClr val="C10E5B"/>
-          </a:solidFill>
-          <a:ln/>
-        </p:spPr>
-      </p:sp>
-      <p:sp>
-        <p:nvSpPr>
-          <p:cNvPr id="46" name="Text 42"/>
-          <p:cNvSpPr/>
-          <p:nvPr/>
-        </p:nvSpPr>
-        <p:spPr>
-          <a:xfrm>
-            <a:off x="8314182" y="4233672"/>
-            <a:ext cx="2660904" cy="169164"/>
+            <a:pPr algn="r" indent="0" marL="0">
+              <a:buNone/>
+            </a:pPr>
+            <a:r>
+              <a:rPr lang="en-US" sz="850" b="1" dirty="0">
+                <a:solidFill>
+                  <a:srgbClr val="2F8F6A"/>
+                </a:solidFill>
+                <a:latin typeface="Calibri" pitchFamily="34" charset="0"/>
+                <a:ea typeface="Calibri" pitchFamily="34" charset="-122"/>
+                <a:cs typeface="Calibri" pitchFamily="34" charset="-120"/>
+              </a:rPr>
+              <a:t>◆ Program handover sign-off</a:t>
+            </a:r>
+            <a:endParaRPr lang="en-US" sz="850" dirty="0"/>
+          </a:p>
+        </p:txBody>
+      </p:sp>
+      <p:sp>
+        <p:nvSpPr>
+          <p:cNvPr id="49" name="Text 45"/>
+          <p:cNvSpPr/>
+          <p:nvPr/>
+        </p:nvSpPr>
+        <p:spPr>
+          <a:xfrm>
+            <a:off x="548640" y="5870448"/>
+            <a:ext cx="11064240" cy="274320"/>
           </a:xfrm>
           <a:prstGeom prst="rect">
             <a:avLst/>
@@ -2239,34 +2362,48 @@
           <a:bodyPr wrap="square" lIns="0" tIns="0" rIns="0" bIns="0" rtlCol="0" anchor="ctr"/>
           <a:lstStyle/>
           <a:p>
-            <a:pPr algn="ctr" indent="0" marL="0">
-              <a:buNone/>
-            </a:pPr>
-            <a:r>
-              <a:rPr lang="en-US" sz="700" i="1" dirty="0">
-                <a:solidFill>
-                  <a:srgbClr val="FFFFFF"/>
-                </a:solidFill>
-                <a:latin typeface="Calibri" pitchFamily="34" charset="0"/>
-                <a:ea typeface="Calibri" pitchFamily="34" charset="-122"/>
-                <a:cs typeface="Calibri" pitchFamily="34" charset="-120"/>
-              </a:rPr>
-              <a:t>Gate 3</a:t>
-            </a:r>
-            <a:endParaRPr lang="en-US" sz="700" dirty="0"/>
-          </a:p>
-        </p:txBody>
-      </p:sp>
-      <p:sp>
-        <p:nvSpPr>
-          <p:cNvPr id="47" name="Text 43"/>
-          <p:cNvSpPr/>
-          <p:nvPr/>
-        </p:nvSpPr>
-        <p:spPr>
-          <a:xfrm>
-            <a:off x="548640" y="4421124"/>
-            <a:ext cx="3017520" cy="242316"/>
+            <a:pPr indent="0" marL="0">
+              <a:buNone/>
+            </a:pPr>
+            <a:r>
+              <a:rPr lang="en-US" sz="1050" b="1" dirty="0">
+                <a:solidFill>
+                  <a:srgbClr val="C10E5B"/>
+                </a:solidFill>
+                <a:latin typeface="Calibri" pitchFamily="34" charset="0"/>
+                <a:ea typeface="Calibri" pitchFamily="34" charset="-122"/>
+                <a:cs typeface="Calibri" pitchFamily="34" charset="-120"/>
+              </a:rPr>
+              <a:t>EY assets:  </a:t>
+            </a:r>
+            <a:pPr indent="0" marL="0">
+              <a:buNone/>
+            </a:pPr>
+            <a:r>
+              <a:rPr lang="en-US" sz="1050" dirty="0">
+                <a:solidFill>
+                  <a:srgbClr val="3F3F48"/>
+                </a:solidFill>
+                <a:latin typeface="Calibri" pitchFamily="34" charset="0"/>
+                <a:ea typeface="Calibri" pitchFamily="34" charset="-122"/>
+                <a:cs typeface="Calibri" pitchFamily="34" charset="-120"/>
+              </a:rPr>
+              <a:t>handover playbook  ·  program asset pack  ·  capability &amp; certification framework  ·  roadmap &amp; backlog register.</a:t>
+            </a:r>
+            <a:endParaRPr lang="en-US" sz="1050" dirty="0"/>
+          </a:p>
+        </p:txBody>
+      </p:sp>
+      <p:sp>
+        <p:nvSpPr>
+          <p:cNvPr id="50" name="Text 46"/>
+          <p:cNvSpPr/>
+          <p:nvPr/>
+        </p:nvSpPr>
+        <p:spPr>
+          <a:xfrm>
+            <a:off x="548640" y="6144768"/>
+            <a:ext cx="11064240" cy="256032"/>
           </a:xfrm>
           <a:prstGeom prst="rect">
             <a:avLst/>
@@ -2282,398 +2419,23 @@
               <a:buNone/>
             </a:pPr>
             <a:r>
-              <a:rPr lang="en-US" sz="950" dirty="0">
-                <a:solidFill>
-                  <a:srgbClr val="3F3F48"/>
-                </a:solidFill>
-                <a:latin typeface="Calibri" pitchFamily="34" charset="0"/>
-                <a:ea typeface="Calibri" pitchFamily="34" charset="-122"/>
-                <a:cs typeface="Calibri" pitchFamily="34" charset="-120"/>
-              </a:rPr>
-              <a:t>Transfer assurance &amp; go-live stabilisation</a:t>
-            </a:r>
-            <a:endParaRPr lang="en-US" sz="950" dirty="0"/>
-          </a:p>
-        </p:txBody>
-      </p:sp>
-      <p:sp>
-        <p:nvSpPr>
-          <p:cNvPr id="48" name="Shape 44"/>
-          <p:cNvSpPr/>
-          <p:nvPr/>
-        </p:nvSpPr>
-        <p:spPr>
-          <a:xfrm>
-            <a:off x="8979408" y="4475988"/>
-            <a:ext cx="1995678" cy="169164"/>
-          </a:xfrm>
-          <a:prstGeom prst="roundRect">
-            <a:avLst>
-              <a:gd name="adj" fmla="val 21622"/>
-            </a:avLst>
-          </a:prstGeom>
-          <a:solidFill>
-            <a:srgbClr val="C10E5B"/>
-          </a:solidFill>
-          <a:ln/>
-        </p:spPr>
-      </p:sp>
-      <p:sp>
-        <p:nvSpPr>
-          <p:cNvPr id="49" name="Text 45"/>
-          <p:cNvSpPr/>
-          <p:nvPr/>
-        </p:nvSpPr>
-        <p:spPr>
-          <a:xfrm>
-            <a:off x="548640" y="4663440"/>
-            <a:ext cx="3017520" cy="242316"/>
-          </a:xfrm>
-          <a:prstGeom prst="rect">
-            <a:avLst/>
-          </a:prstGeom>
-          <a:noFill/>
-          <a:ln/>
-        </p:spPr>
-        <p:txBody>
-          <a:bodyPr wrap="square" lIns="0" tIns="0" rIns="0" bIns="0" rtlCol="0" anchor="ctr"/>
-          <a:lstStyle/>
-          <a:p>
-            <a:pPr indent="0" marL="0">
-              <a:buNone/>
-            </a:pPr>
-            <a:r>
-              <a:rPr lang="en-US" sz="950" dirty="0">
-                <a:solidFill>
-                  <a:srgbClr val="3F3F48"/>
-                </a:solidFill>
-                <a:latin typeface="Calibri" pitchFamily="34" charset="0"/>
-                <a:ea typeface="Calibri" pitchFamily="34" charset="-122"/>
-                <a:cs typeface="Calibri" pitchFamily="34" charset="-120"/>
-              </a:rPr>
-              <a:t>Sign-off &amp; post-transfer assistance</a:t>
-            </a:r>
-            <a:endParaRPr lang="en-US" sz="950" dirty="0"/>
-          </a:p>
-        </p:txBody>
-      </p:sp>
-      <p:sp>
-        <p:nvSpPr>
-          <p:cNvPr id="50" name="Shape 46"/>
-          <p:cNvSpPr/>
-          <p:nvPr/>
-        </p:nvSpPr>
-        <p:spPr>
-          <a:xfrm>
-            <a:off x="10309860" y="4718304"/>
-            <a:ext cx="1330452" cy="169164"/>
-          </a:xfrm>
-          <a:prstGeom prst="roundRect">
-            <a:avLst>
-              <a:gd name="adj" fmla="val 21622"/>
-            </a:avLst>
-          </a:prstGeom>
-          <a:solidFill>
-            <a:srgbClr val="2F8F6A"/>
-          </a:solidFill>
-          <a:ln/>
-        </p:spPr>
-      </p:sp>
-      <p:sp>
-        <p:nvSpPr>
-          <p:cNvPr id="51" name="Text 47"/>
-          <p:cNvSpPr/>
-          <p:nvPr/>
-        </p:nvSpPr>
-        <p:spPr>
-          <a:xfrm>
-            <a:off x="10309860" y="4718304"/>
-            <a:ext cx="1330452" cy="169164"/>
-          </a:xfrm>
-          <a:prstGeom prst="rect">
-            <a:avLst/>
-          </a:prstGeom>
-          <a:noFill/>
-          <a:ln/>
-        </p:spPr>
-        <p:txBody>
-          <a:bodyPr wrap="square" lIns="0" tIns="0" rIns="0" bIns="0" rtlCol="0" anchor="ctr"/>
-          <a:lstStyle/>
-          <a:p>
-            <a:pPr algn="ctr" indent="0" marL="0">
-              <a:buNone/>
-            </a:pPr>
-            <a:r>
-              <a:rPr lang="en-US" sz="700" i="1" dirty="0">
-                <a:solidFill>
-                  <a:srgbClr val="FFFFFF"/>
-                </a:solidFill>
-                <a:latin typeface="Calibri" pitchFamily="34" charset="0"/>
-                <a:ea typeface="Calibri" pitchFamily="34" charset="-122"/>
-                <a:cs typeface="Calibri" pitchFamily="34" charset="-120"/>
-              </a:rPr>
-              <a:t>Gate 4</a:t>
-            </a:r>
-            <a:endParaRPr lang="en-US" sz="700" dirty="0"/>
-          </a:p>
-        </p:txBody>
-      </p:sp>
-      <p:sp>
-        <p:nvSpPr>
-          <p:cNvPr id="52" name="Text 48"/>
-          <p:cNvSpPr/>
-          <p:nvPr/>
-        </p:nvSpPr>
-        <p:spPr>
-          <a:xfrm>
-            <a:off x="548640" y="4960620"/>
-            <a:ext cx="10972800" cy="182880"/>
-          </a:xfrm>
-          <a:prstGeom prst="rect">
-            <a:avLst/>
-          </a:prstGeom>
-          <a:noFill/>
-          <a:ln/>
-        </p:spPr>
-        <p:txBody>
-          <a:bodyPr wrap="square" lIns="0" tIns="0" rIns="0" bIns="0" rtlCol="0" anchor="ctr"/>
-          <a:lstStyle/>
-          <a:p>
-            <a:pPr indent="0" marL="0">
-              <a:buNone/>
-            </a:pPr>
-            <a:r>
-              <a:rPr lang="en-US" sz="1050" b="1" dirty="0">
-                <a:solidFill>
-                  <a:srgbClr val="9A9AA2"/>
-                </a:solidFill>
-                <a:latin typeface="Calibri" pitchFamily="34" charset="0"/>
-                <a:ea typeface="Calibri" pitchFamily="34" charset="-122"/>
-                <a:cs typeface="Calibri" pitchFamily="34" charset="-120"/>
-              </a:rPr>
-              <a:t>Track B — Optional transfer to third-party GCC/BPO provider</a:t>
-            </a:r>
-            <a:endParaRPr lang="en-US" sz="1050" dirty="0"/>
-          </a:p>
-        </p:txBody>
-      </p:sp>
-      <p:sp>
-        <p:nvSpPr>
-          <p:cNvPr id="53" name="Text 49"/>
-          <p:cNvSpPr/>
-          <p:nvPr/>
-        </p:nvSpPr>
-        <p:spPr>
-          <a:xfrm>
-            <a:off x="548640" y="5404104"/>
-            <a:ext cx="3017520" cy="242316"/>
-          </a:xfrm>
-          <a:prstGeom prst="rect">
-            <a:avLst/>
-          </a:prstGeom>
-          <a:noFill/>
-          <a:ln/>
-        </p:spPr>
-        <p:txBody>
-          <a:bodyPr wrap="square" lIns="0" tIns="0" rIns="0" bIns="0" rtlCol="0" anchor="ctr"/>
-          <a:lstStyle/>
-          <a:p>
-            <a:pPr indent="0" marL="0">
-              <a:buNone/>
-            </a:pPr>
-            <a:r>
-              <a:rPr lang="en-US" sz="950" dirty="0">
-                <a:solidFill>
-                  <a:srgbClr val="3F3F48"/>
-                </a:solidFill>
-                <a:latin typeface="Calibri" pitchFamily="34" charset="0"/>
-                <a:ea typeface="Calibri" pitchFamily="34" charset="-122"/>
-                <a:cs typeface="Calibri" pitchFamily="34" charset="-120"/>
-              </a:rPr>
-              <a:t>Vendor onboarding &amp; resource rebadging</a:t>
-            </a:r>
-            <a:endParaRPr lang="en-US" sz="950" dirty="0"/>
-          </a:p>
-        </p:txBody>
-      </p:sp>
-      <p:sp>
-        <p:nvSpPr>
-          <p:cNvPr id="54" name="Shape 50"/>
-          <p:cNvSpPr/>
-          <p:nvPr/>
-        </p:nvSpPr>
-        <p:spPr>
-          <a:xfrm>
-            <a:off x="3657600" y="5458968"/>
-            <a:ext cx="3991356" cy="169164"/>
-          </a:xfrm>
-          <a:prstGeom prst="roundRect">
-            <a:avLst>
-              <a:gd name="adj" fmla="val 21622"/>
-            </a:avLst>
-          </a:prstGeom>
-          <a:solidFill>
-            <a:srgbClr val="9A9AA2"/>
-          </a:solidFill>
-          <a:ln/>
-        </p:spPr>
-      </p:sp>
-      <p:sp>
-        <p:nvSpPr>
-          <p:cNvPr id="55" name="Text 51"/>
-          <p:cNvSpPr/>
-          <p:nvPr/>
-        </p:nvSpPr>
-        <p:spPr>
-          <a:xfrm>
-            <a:off x="548640" y="5646420"/>
-            <a:ext cx="3017520" cy="242316"/>
-          </a:xfrm>
-          <a:prstGeom prst="rect">
-            <a:avLst/>
-          </a:prstGeom>
-          <a:noFill/>
-          <a:ln/>
-        </p:spPr>
-        <p:txBody>
-          <a:bodyPr wrap="square" lIns="0" tIns="0" rIns="0" bIns="0" rtlCol="0" anchor="ctr"/>
-          <a:lstStyle/>
-          <a:p>
-            <a:pPr indent="0" marL="0">
-              <a:buNone/>
-            </a:pPr>
-            <a:r>
-              <a:rPr lang="en-US" sz="950" dirty="0">
-                <a:solidFill>
-                  <a:srgbClr val="3F3F48"/>
-                </a:solidFill>
-                <a:latin typeface="Calibri" pitchFamily="34" charset="0"/>
-                <a:ea typeface="Calibri" pitchFamily="34" charset="-122"/>
-                <a:cs typeface="Calibri" pitchFamily="34" charset="-120"/>
-              </a:rPr>
-              <a:t>Transition dashboards &amp; performance monitoring</a:t>
-            </a:r>
-            <a:endParaRPr lang="en-US" sz="950" dirty="0"/>
-          </a:p>
-        </p:txBody>
-      </p:sp>
-      <p:sp>
-        <p:nvSpPr>
-          <p:cNvPr id="56" name="Shape 52"/>
-          <p:cNvSpPr/>
-          <p:nvPr/>
-        </p:nvSpPr>
-        <p:spPr>
-          <a:xfrm>
-            <a:off x="6318504" y="5701284"/>
-            <a:ext cx="5321808" cy="169164"/>
-          </a:xfrm>
-          <a:prstGeom prst="roundRect">
-            <a:avLst>
-              <a:gd name="adj" fmla="val 21622"/>
-            </a:avLst>
-          </a:prstGeom>
-          <a:solidFill>
-            <a:srgbClr val="9A9AA2"/>
-          </a:solidFill>
-          <a:ln/>
-        </p:spPr>
-      </p:sp>
-      <p:sp>
-        <p:nvSpPr>
-          <p:cNvPr id="57" name="Text 53"/>
-          <p:cNvSpPr/>
-          <p:nvPr/>
-        </p:nvSpPr>
-        <p:spPr>
-          <a:xfrm>
-            <a:off x="10126980" y="2615184"/>
-            <a:ext cx="1737360" cy="182880"/>
-          </a:xfrm>
-          <a:prstGeom prst="rect">
-            <a:avLst/>
-          </a:prstGeom>
-          <a:noFill/>
-          <a:ln/>
-        </p:spPr>
-        <p:txBody>
-          <a:bodyPr wrap="square" lIns="0" tIns="0" rIns="0" bIns="0" rtlCol="0" anchor="ctr"/>
-          <a:lstStyle/>
-          <a:p>
-            <a:pPr algn="ctr" indent="0" marL="0">
-              <a:buNone/>
-            </a:pPr>
-            <a:r>
-              <a:rPr lang="en-US" sz="850" b="1" dirty="0">
-                <a:solidFill>
-                  <a:srgbClr val="2F8F6A"/>
-                </a:solidFill>
-                <a:latin typeface="Calibri" pitchFamily="34" charset="0"/>
-                <a:ea typeface="Calibri" pitchFamily="34" charset="-122"/>
-                <a:cs typeface="Calibri" pitchFamily="34" charset="-120"/>
-              </a:rPr>
-              <a:t>◆ RCPL independent</a:t>
-            </a:r>
-            <a:endParaRPr lang="en-US" sz="850" dirty="0"/>
-          </a:p>
-        </p:txBody>
-      </p:sp>
-      <p:sp>
-        <p:nvSpPr>
-          <p:cNvPr id="58" name="Text 54"/>
-          <p:cNvSpPr/>
-          <p:nvPr/>
-        </p:nvSpPr>
-        <p:spPr>
-          <a:xfrm>
-            <a:off x="548640" y="5989320"/>
-            <a:ext cx="11064240" cy="274320"/>
-          </a:xfrm>
-          <a:prstGeom prst="rect">
-            <a:avLst/>
-          </a:prstGeom>
-          <a:noFill/>
-          <a:ln/>
-        </p:spPr>
-        <p:txBody>
-          <a:bodyPr wrap="square" lIns="0" tIns="0" rIns="0" bIns="0" rtlCol="0" anchor="ctr"/>
-          <a:lstStyle/>
-          <a:p>
-            <a:pPr indent="0" marL="0">
-              <a:buNone/>
-            </a:pPr>
-            <a:r>
-              <a:rPr lang="en-US" sz="1050" b="1" dirty="0">
-                <a:solidFill>
-                  <a:srgbClr val="C10E5B"/>
-                </a:solidFill>
-                <a:latin typeface="Calibri" pitchFamily="34" charset="0"/>
-                <a:ea typeface="Calibri" pitchFamily="34" charset="-122"/>
-                <a:cs typeface="Calibri" pitchFamily="34" charset="-120"/>
-              </a:rPr>
-              <a:t>EY assets:  </a:t>
-            </a:r>
-            <a:pPr indent="0" marL="0">
-              <a:buNone/>
-            </a:pPr>
-            <a:r>
-              <a:rPr lang="en-US" sz="1050" dirty="0">
-                <a:solidFill>
-                  <a:srgbClr val="3F3F48"/>
-                </a:solidFill>
-                <a:latin typeface="Calibri" pitchFamily="34" charset="0"/>
-                <a:ea typeface="Calibri" pitchFamily="34" charset="-122"/>
-                <a:cs typeface="Calibri" pitchFamily="34" charset="-120"/>
-              </a:rPr>
-              <a:t>transfer checklist  ·  handover playbook  ·  talent rebadging &amp; vendor onboarding plan.</a:t>
-            </a:r>
-            <a:endParaRPr lang="en-US" sz="1050" dirty="0"/>
+              <a:rPr lang="en-US" sz="1100" b="1" i="1" dirty="0">
+                <a:solidFill>
+                  <a:srgbClr val="7A2A8F"/>
+                </a:solidFill>
+                <a:latin typeface="Calibri" pitchFamily="34" charset="0"/>
+                <a:ea typeface="Calibri" pitchFamily="34" charset="-122"/>
+                <a:cs typeface="Calibri" pitchFamily="34" charset="-120"/>
+              </a:rPr>
+              <a:t>Outcome — RCPL’s transformation team owns and evolves the SSC and AI factory independently; EY moves to advisory-only.</a:t>
+            </a:r>
+            <a:endParaRPr lang="en-US" sz="1100" dirty="0"/>
           </a:p>
         </p:txBody>
       </p:sp>
       <p:pic>
         <p:nvPicPr>
-          <p:cNvPr id="59" name="Image 2" descr="preencoded.png">    </p:cNvPr>
+          <p:cNvPr id="51" name="Image 2" descr="preencoded.png">    </p:cNvPr>
           <p:cNvPicPr>
             <a:picLocks noChangeAspect="1"/>
           </p:cNvPicPr>
@@ -2687,8 +2449,8 @@
         </p:blipFill>
         <p:spPr>
           <a:xfrm>
-            <a:off x="365760" y="6437376"/>
-            <a:ext cx="457200" cy="301752"/>
+            <a:off x="365760" y="6455664"/>
+            <a:ext cx="457200" cy="292608"/>
           </a:xfrm>
           <a:prstGeom prst="rect">
             <a:avLst/>
@@ -2697,14 +2459,14 @@
       </p:pic>
       <p:sp>
         <p:nvSpPr>
-          <p:cNvPr id="60" name="Text 55"/>
-          <p:cNvSpPr/>
-          <p:nvPr/>
-        </p:nvSpPr>
-        <p:spPr>
-          <a:xfrm>
-            <a:off x="365760" y="6437376"/>
-            <a:ext cx="457200" cy="301752"/>
+          <p:cNvPr id="52" name="Text 47"/>
+          <p:cNvSpPr/>
+          <p:nvPr/>
+        </p:nvSpPr>
+        <p:spPr>
+          <a:xfrm>
+            <a:off x="365760" y="6455664"/>
+            <a:ext cx="457200" cy="292608"/>
           </a:xfrm>
           <a:prstGeom prst="rect">
             <a:avLst/>
@@ -2736,14 +2498,14 @@
       </p:sp>
       <p:sp>
         <p:nvSpPr>
-          <p:cNvPr id="61" name="Text 56"/>
-          <p:cNvSpPr/>
-          <p:nvPr/>
-        </p:nvSpPr>
-        <p:spPr>
-          <a:xfrm>
-            <a:off x="914400" y="6437376"/>
-            <a:ext cx="8229600" cy="301752"/>
+          <p:cNvPr id="53" name="Text 48"/>
+          <p:cNvSpPr/>
+          <p:nvPr/>
+        </p:nvSpPr>
+        <p:spPr>
+          <a:xfrm>
+            <a:off x="914400" y="6455664"/>
+            <a:ext cx="8229600" cy="292608"/>
           </a:xfrm>
           <a:prstGeom prst="rect">
             <a:avLst/>
@@ -2775,14 +2537,14 @@
       </p:sp>
       <p:sp>
         <p:nvSpPr>
-          <p:cNvPr id="62" name="Shape 57"/>
-          <p:cNvSpPr/>
-          <p:nvPr/>
-        </p:nvSpPr>
-        <p:spPr>
-          <a:xfrm>
-            <a:off x="11109960" y="6419088"/>
-            <a:ext cx="384048" cy="301752"/>
+          <p:cNvPr id="54" name="Shape 49"/>
+          <p:cNvSpPr/>
+          <p:nvPr/>
+        </p:nvSpPr>
+        <p:spPr>
+          <a:xfrm>
+            <a:off x="11109960" y="6437376"/>
+            <a:ext cx="384048" cy="292608"/>
           </a:xfrm>
           <a:prstGeom prst="parallelogram">
             <a:avLst/>
@@ -2795,13 +2557,13 @@
       </p:sp>
       <p:sp>
         <p:nvSpPr>
-          <p:cNvPr id="63" name="Text 58"/>
-          <p:cNvSpPr/>
-          <p:nvPr/>
-        </p:nvSpPr>
-        <p:spPr>
-          <a:xfrm>
-            <a:off x="11384280" y="6400800"/>
+          <p:cNvPr id="55" name="Text 50"/>
+          <p:cNvSpPr/>
+          <p:nvPr/>
+        </p:nvSpPr>
+        <p:spPr>
+          <a:xfrm>
+            <a:off x="11384280" y="6419088"/>
             <a:ext cx="640080" cy="365760"/>
           </a:xfrm>
           <a:prstGeom prst="rect">

</xml_diff>